<commit_message>
docs(presentation): mentionner le relevé de vent aberrant dans les limites
Un vent de 1 048 mph le 12/02 contre 40 mph au second maximum : une seule
ligne suffisait à rendre le graphique du vent inutilisable. C'est l'exemple le
plus parlant de la slide sur les limites du jeu de données.
</commit_message>
<xml_diff>
--- a/presentation/Trafic_Aerien_ADP_presentation.pptx
+++ b/presentation/Trafic_Aerien_ADP_presentation.pptx
@@ -991,7 +991,7 @@
           <a:p>
             <a:r>
               <a:rPr lang="en-US" dirty="0"/>
-              <a:t>Un dashboard qui affiche une courbe continue là où il n'y a pas de données ment à son lecteur. Chaque limite est écrite à l'écran, à côté du graphique concerné.</a:t>
+              <a:t>Un dashboard qui affiche une courbe continue là où il n'y a pas de données ment à son lecteur. Chaque limite est écrite à l'écran, à côté du graphique concerné. Le relevé de vent à 1 048 mph est le meilleur exemple : une seule ligne aberrante rendait le graphique du vent inutilisable.</a:t>
             </a:r>
             <a:endParaRPr lang="en-US" dirty="0"/>
           </a:p>
@@ -3603,7 +3603,7 @@
                 <a:ea typeface="Cambria" pitchFamily="34" charset="-122"/>
                 <a:cs typeface="Cambria" pitchFamily="34" charset="-120"/>
               </a:rPr>
-              <a:t>Météo limitée à un aéroport</a:t>
+              <a:t>Météo : un aéroport, et un relevé impossible</a:t>
             </a:r>
             <a:endParaRPr lang="en-US" sz="1450" dirty="0"/>
           </a:p>
@@ -3645,7 +3645,7 @@
                 <a:ea typeface="Calibri" pitchFamily="34" charset="-122"/>
                 <a:cs typeface="Calibri" pitchFamily="34" charset="-120"/>
               </a:rPr>
-              <a:t>L'extrait weather.pdf ne couvre qu'EWR, de janvier à mai. L'onglet Météo ne propose donc que cet aéroport plutôt qu'un écran vide sur JFK et LGA.</a:t>
+              <a:t>weather.pdf ne couvre qu'EWR de janvier à mai — l'onglet ne propose donc que cet aéroport. Il contient aussi un vent de 1 048 mph le 12/02, contre 40 mph au second maximum : écarté du tracé et des moyennes.</a:t>
             </a:r>
             <a:endParaRPr lang="en-US" sz="1150" dirty="0"/>
           </a:p>

</xml_diff>

<commit_message>
refactor(presentation): confier la demonstration live a Hedi
La demonstration du dashboard passe de Marcus a Hedi : c'est son API que
l'application interroge, donc c'est lui qui peut repondre si le jury demande
d'ou sort un chiffre affiche pendant la manipulation.

La slide 11 porte desormais deux captures, vue d'ensemble et carte du reseau,
qui servent de repli si l'application ne demarre pas le jour J : la presentation
se fait alors sur les images sans rien changer au discours.

Repartition apres ce changement :

  Salma  1, 2, 3
  Meissa 4, 5
  Hedi   6, 7, 11
  Hassan 8, 9, 10
  Marcus 12, 13
</commit_message>
<xml_diff>
--- a/presentation/Trafic_Aerien_ADP_presentation.pptx
+++ b/presentation/Trafic_Aerien_ADP_presentation.pptx
@@ -690,7 +690,7 @@
           <a:p>
             <a:r>
               <a:rPr lang="en-US" dirty="0"/>
-              <a:t>C'est ici que je fais la démonstration live. Enchaînement conseillé : l'onglet Vols pour montrer que les filtres, le tri et la pagination sont exécutés par l'API et que le dashboard ne charge qu'une page à la fois, puis la carte, puis les prévisions.</a:t>
+              <a:t>Hedi mène la démonstration live, sur son poste : c'est son API que le dashboard interroge, donc c'est lui qui peut répondre si on demande d'où sort un chiffre. Parcours conseillé, trois minutes : l'onglet Vols pour montrer que les filtres, le tri et la pagination sont exécutés par l'API et que le dashboard ne charge qu'une page à la fois ; la Carte pour l'interactivité ; puis passer la main à Marcus sur l'onglet Prévisions. Les deux captures de cette slide servent de repli : si l'application ne démarre pas, on présente sur les images sans rien changer au discours. À faire tourner une fois avant la soutenance, avec les trois commandes de la dernière slide.</a:t>
             </a:r>
             <a:endParaRPr lang="en-US" dirty="0"/>
           </a:p>
@@ -2910,7 +2910,7 @@
                 <a:ea typeface="Calibri" pitchFamily="34" charset="-122"/>
                 <a:cs typeface="Calibri" pitchFamily="34" charset="-120"/>
               </a:rPr>
-              <a:t>BLOC 3 — REPORTING  ·  MARCUS</a:t>
+              <a:t>BLOC 3 — DÉMONSTRATION  ·  HEDI</a:t>
             </a:r>
             <a:endParaRPr lang="en-US" sz="1200" dirty="0"/>
           </a:p>
@@ -2972,7 +2972,7 @@
         <p:spPr>
           <a:xfrm>
             <a:off x="566928" y="1371600"/>
-            <a:ext cx="4892040" cy="4572000"/>
+            <a:ext cx="3977640" cy="3712464"/>
           </a:xfrm>
           <a:prstGeom prst="rect">
             <a:avLst/>
@@ -2981,14 +2981,155 @@
       </p:pic>
       <p:sp>
         <p:nvSpPr>
-          <p:cNvPr id="5" name="Shape 2"/>
+          <p:cNvPr id="5" name="Text 2"/>
+          <p:cNvSpPr txBox="1"/>
+          <p:nvPr/>
+        </p:nvSpPr>
+        <p:spPr>
+          <a:xfrm>
+            <a:off x="566928" y="5138928"/>
+            <a:ext cx="3977640" cy="256032"/>
+          </a:xfrm>
+          <a:prstGeom prst="rect">
+            <a:avLst/>
+          </a:prstGeom>
+          <a:noFill/>
+          <a:ln/>
+        </p:spPr>
+        <p:txBody>
+          <a:bodyPr wrap="square" lIns="0" tIns="0" rIns="0" bIns="0" rtlCol="0" anchor="ctr"/>
+          <a:lstStyle/>
+          <a:p>
+            <a:pPr algn="ctr" indent="0" marL="0">
+              <a:buNone/>
+            </a:pPr>
+            <a:r>
+              <a:rPr lang="en-US" sz="1000" i="1" dirty="0">
+                <a:solidFill>
+                  <a:srgbClr val="5A6B7B"/>
+                </a:solidFill>
+                <a:latin typeface="Calibri" pitchFamily="34" charset="0"/>
+                <a:ea typeface="Calibri" pitchFamily="34" charset="-122"/>
+                <a:cs typeface="Calibri" pitchFamily="34" charset="-120"/>
+              </a:rPr>
+              <a:t>Vue d'ensemble — les indicateurs de cadrage</a:t>
+            </a:r>
+            <a:endParaRPr lang="en-US" sz="1000" dirty="0"/>
+          </a:p>
+        </p:txBody>
+      </p:sp>
+      <p:pic>
+        <p:nvPicPr>
+          <p:cNvPr id="6" name="Image 1" descr="/Users/marcuslinguet/Downloads/trafic-aerien-adp/presentation/figures/11_dashboard_carte.png">    </p:cNvPr>
+          <p:cNvPicPr>
+            <a:picLocks noChangeAspect="1"/>
+          </p:cNvPicPr>
+          <p:nvPr/>
+        </p:nvPicPr>
+        <p:blipFill>
+          <a:blip r:embed="rId2"/>
+          <a:stretch>
+            <a:fillRect/>
+          </a:stretch>
+        </p:blipFill>
+        <p:spPr>
+          <a:xfrm>
+            <a:off x="4800600" y="1371600"/>
+            <a:ext cx="3977640" cy="3493008"/>
+          </a:xfrm>
+          <a:prstGeom prst="rect">
+            <a:avLst/>
+          </a:prstGeom>
+        </p:spPr>
+      </p:pic>
+      <p:sp>
+        <p:nvSpPr>
+          <p:cNvPr id="7" name="Text 3"/>
+          <p:cNvSpPr txBox="1"/>
+          <p:nvPr/>
+        </p:nvSpPr>
+        <p:spPr>
+          <a:xfrm>
+            <a:off x="4800600" y="4919472"/>
+            <a:ext cx="3977640" cy="256032"/>
+          </a:xfrm>
+          <a:prstGeom prst="rect">
+            <a:avLst/>
+          </a:prstGeom>
+          <a:noFill/>
+          <a:ln/>
+        </p:spPr>
+        <p:txBody>
+          <a:bodyPr wrap="square" lIns="0" tIns="0" rIns="0" bIns="0" rtlCol="0" anchor="ctr"/>
+          <a:lstStyle/>
+          <a:p>
+            <a:pPr algn="ctr" indent="0" marL="0">
+              <a:buNone/>
+            </a:pPr>
+            <a:r>
+              <a:rPr lang="en-US" sz="1000" i="1" dirty="0">
+                <a:solidFill>
+                  <a:srgbClr val="5A6B7B"/>
+                </a:solidFill>
+                <a:latin typeface="Calibri" pitchFamily="34" charset="0"/>
+                <a:ea typeface="Calibri" pitchFamily="34" charset="-122"/>
+                <a:cs typeface="Calibri" pitchFamily="34" charset="-120"/>
+              </a:rPr>
+              <a:t>Carte du réseau — l'épaisseur du trait suit le trafic</a:t>
+            </a:r>
+            <a:endParaRPr lang="en-US" sz="1000" dirty="0"/>
+          </a:p>
+        </p:txBody>
+      </p:sp>
+      <p:sp>
+        <p:nvSpPr>
+          <p:cNvPr id="8" name="Text 4"/>
+          <p:cNvSpPr txBox="1"/>
+          <p:nvPr/>
+        </p:nvSpPr>
+        <p:spPr>
+          <a:xfrm>
+            <a:off x="9144000" y="1371600"/>
+            <a:ext cx="2496312" cy="274320"/>
+          </a:xfrm>
+          <a:prstGeom prst="rect">
+            <a:avLst/>
+          </a:prstGeom>
+          <a:noFill/>
+          <a:ln/>
+        </p:spPr>
+        <p:txBody>
+          <a:bodyPr wrap="square" lIns="0" tIns="0" rIns="0" bIns="0" rtlCol="0" anchor="ctr"/>
+          <a:lstStyle/>
+          <a:p>
+            <a:pPr indent="0" marL="0">
+              <a:buNone/>
+            </a:pPr>
+            <a:r>
+              <a:rPr lang="en-US" sz="1400" b="1" dirty="0">
+                <a:solidFill>
+                  <a:srgbClr val="12202B"/>
+                </a:solidFill>
+                <a:latin typeface="Cambria" pitchFamily="34" charset="0"/>
+                <a:ea typeface="Cambria" pitchFamily="34" charset="-122"/>
+                <a:cs typeface="Cambria" pitchFamily="34" charset="-120"/>
+              </a:rPr>
+              <a:t>Les neuf onglets</a:t>
+            </a:r>
+            <a:endParaRPr lang="en-US" sz="1400" dirty="0"/>
+          </a:p>
+        </p:txBody>
+      </p:sp>
+      <p:sp>
+        <p:nvSpPr>
+          <p:cNvPr id="9" name="Shape 5"/>
           <p:cNvSpPr/>
           <p:nvPr/>
         </p:nvSpPr>
         <p:spPr>
           <a:xfrm>
-            <a:off x="5806440" y="1517904"/>
-            <a:ext cx="274320" cy="274320"/>
+            <a:off x="9144000" y="1755648"/>
+            <a:ext cx="237744" cy="237744"/>
           </a:xfrm>
           <a:prstGeom prst="ellipse">
             <a:avLst/>
@@ -3006,14 +3147,14 @@
       </p:sp>
       <p:sp>
         <p:nvSpPr>
-          <p:cNvPr id="6" name="Text 3"/>
-          <p:cNvSpPr txBox="1"/>
-          <p:nvPr/>
-        </p:nvSpPr>
-        <p:spPr>
-          <a:xfrm>
-            <a:off x="5806440" y="1545336"/>
-            <a:ext cx="274320" cy="237744"/>
+          <p:cNvPr id="10" name="Text 6"/>
+          <p:cNvSpPr txBox="1"/>
+          <p:nvPr/>
+        </p:nvSpPr>
+        <p:spPr>
+          <a:xfrm>
+            <a:off x="9144000" y="1773936"/>
+            <a:ext cx="237744" cy="201168"/>
           </a:xfrm>
           <a:prstGeom prst="rect">
             <a:avLst/>
@@ -3029,7 +3170,7 @@
               <a:buNone/>
             </a:pPr>
             <a:r>
-              <a:rPr lang="en-US" sz="1000" b="1" dirty="0">
+              <a:rPr lang="en-US" sz="900" b="1" dirty="0">
                 <a:solidFill>
                   <a:srgbClr val="FFFFFF"/>
                 </a:solidFill>
@@ -3039,45 +3180,31 @@
               </a:rPr>
               <a:t>1</a:t>
             </a:r>
-            <a:endParaRPr lang="en-US" sz="1000" dirty="0"/>
-          </a:p>
-        </p:txBody>
-      </p:sp>
-      <p:sp>
-        <p:nvSpPr>
-          <p:cNvPr id="7" name="Text 4"/>
-          <p:cNvSpPr txBox="1"/>
-          <p:nvPr/>
-        </p:nvSpPr>
-        <p:spPr>
-          <a:xfrm>
-            <a:off x="6236208" y="1463040"/>
-            <a:ext cx="5394960" cy="384048"/>
-          </a:xfrm>
-          <a:prstGeom prst="rect">
-            <a:avLst/>
-          </a:prstGeom>
-          <a:noFill/>
-          <a:ln/>
-        </p:spPr>
-        <p:txBody>
-          <a:bodyPr wrap="square" lIns="0" tIns="0" rIns="0" bIns="0" rtlCol="0" anchor="ctr"/>
-          <a:lstStyle/>
-          <a:p>
-            <a:pPr indent="0" marL="0">
-              <a:buNone/>
-            </a:pPr>
-            <a:r>
-              <a:rPr lang="en-US" sz="1250" b="1" dirty="0">
-                <a:solidFill>
-                  <a:srgbClr val="12202B"/>
-                </a:solidFill>
-                <a:latin typeface="Calibri" pitchFamily="34" charset="0"/>
-                <a:ea typeface="Calibri" pitchFamily="34" charset="-122"/>
-                <a:cs typeface="Calibri" pitchFamily="34" charset="-120"/>
-              </a:rPr>
-              <a:t>Vue d'ensemble  </a:t>
-            </a:r>
+            <a:endParaRPr lang="en-US" sz="900" dirty="0"/>
+          </a:p>
+        </p:txBody>
+      </p:sp>
+      <p:sp>
+        <p:nvSpPr>
+          <p:cNvPr id="11" name="Text 7"/>
+          <p:cNvSpPr txBox="1"/>
+          <p:nvPr/>
+        </p:nvSpPr>
+        <p:spPr>
+          <a:xfrm>
+            <a:off x="9509760" y="1719072"/>
+            <a:ext cx="2148840" cy="310896"/>
+          </a:xfrm>
+          <a:prstGeom prst="rect">
+            <a:avLst/>
+          </a:prstGeom>
+          <a:noFill/>
+          <a:ln/>
+        </p:spPr>
+        <p:txBody>
+          <a:bodyPr wrap="square" lIns="0" tIns="0" rIns="0" bIns="0" rtlCol="0" anchor="ctr"/>
+          <a:lstStyle/>
+          <a:p>
             <a:pPr indent="0" marL="0">
               <a:buNone/>
             </a:pPr>
@@ -3090,22 +3217,22 @@
                 <a:ea typeface="Calibri" pitchFamily="34" charset="-122"/>
                 <a:cs typeface="Calibri" pitchFamily="34" charset="-120"/>
               </a:rPr>
-              <a:t>volumétrie et cadrage</a:t>
-            </a:r>
-            <a:endParaRPr lang="en-US" sz="1250" dirty="0"/>
-          </a:p>
-        </p:txBody>
-      </p:sp>
-      <p:sp>
-        <p:nvSpPr>
-          <p:cNvPr id="8" name="Shape 5"/>
+              <a:t>Vue d'ensemble</a:t>
+            </a:r>
+            <a:endParaRPr lang="en-US" sz="1100" dirty="0"/>
+          </a:p>
+        </p:txBody>
+      </p:sp>
+      <p:sp>
+        <p:nvSpPr>
+          <p:cNvPr id="12" name="Shape 8"/>
           <p:cNvSpPr/>
           <p:nvPr/>
         </p:nvSpPr>
         <p:spPr>
           <a:xfrm>
-            <a:off x="5806440" y="2029968"/>
-            <a:ext cx="274320" cy="274320"/>
+            <a:off x="9144000" y="2103120"/>
+            <a:ext cx="237744" cy="237744"/>
           </a:xfrm>
           <a:prstGeom prst="ellipse">
             <a:avLst/>
@@ -3123,14 +3250,14 @@
       </p:sp>
       <p:sp>
         <p:nvSpPr>
-          <p:cNvPr id="9" name="Text 6"/>
-          <p:cNvSpPr txBox="1"/>
-          <p:nvPr/>
-        </p:nvSpPr>
-        <p:spPr>
-          <a:xfrm>
-            <a:off x="5806440" y="2057400"/>
-            <a:ext cx="274320" cy="237744"/>
+          <p:cNvPr id="13" name="Text 9"/>
+          <p:cNvSpPr txBox="1"/>
+          <p:nvPr/>
+        </p:nvSpPr>
+        <p:spPr>
+          <a:xfrm>
+            <a:off x="9144000" y="2121408"/>
+            <a:ext cx="237744" cy="201168"/>
           </a:xfrm>
           <a:prstGeom prst="rect">
             <a:avLst/>
@@ -3146,7 +3273,7 @@
               <a:buNone/>
             </a:pPr>
             <a:r>
-              <a:rPr lang="en-US" sz="1000" b="1" dirty="0">
+              <a:rPr lang="en-US" sz="900" b="1" dirty="0">
                 <a:solidFill>
                   <a:srgbClr val="FFFFFF"/>
                 </a:solidFill>
@@ -3156,45 +3283,31 @@
               </a:rPr>
               <a:t>2</a:t>
             </a:r>
-            <a:endParaRPr lang="en-US" sz="1000" dirty="0"/>
-          </a:p>
-        </p:txBody>
-      </p:sp>
-      <p:sp>
-        <p:nvSpPr>
-          <p:cNvPr id="10" name="Text 7"/>
-          <p:cNvSpPr txBox="1"/>
-          <p:nvPr/>
-        </p:nvSpPr>
-        <p:spPr>
-          <a:xfrm>
-            <a:off x="6236208" y="1975104"/>
-            <a:ext cx="5394960" cy="384048"/>
-          </a:xfrm>
-          <a:prstGeom prst="rect">
-            <a:avLst/>
-          </a:prstGeom>
-          <a:noFill/>
-          <a:ln/>
-        </p:spPr>
-        <p:txBody>
-          <a:bodyPr wrap="square" lIns="0" tIns="0" rIns="0" bIns="0" rtlCol="0" anchor="ctr"/>
-          <a:lstStyle/>
-          <a:p>
-            <a:pPr indent="0" marL="0">
-              <a:buNone/>
-            </a:pPr>
-            <a:r>
-              <a:rPr lang="en-US" sz="1250" b="1" dirty="0">
-                <a:solidFill>
-                  <a:srgbClr val="12202B"/>
-                </a:solidFill>
-                <a:latin typeface="Calibri" pitchFamily="34" charset="0"/>
-                <a:ea typeface="Calibri" pitchFamily="34" charset="-122"/>
-                <a:cs typeface="Calibri" pitchFamily="34" charset="-120"/>
-              </a:rPr>
-              <a:t>Trafic  </a:t>
-            </a:r>
+            <a:endParaRPr lang="en-US" sz="900" dirty="0"/>
+          </a:p>
+        </p:txBody>
+      </p:sp>
+      <p:sp>
+        <p:nvSpPr>
+          <p:cNvPr id="14" name="Text 10"/>
+          <p:cNvSpPr txBox="1"/>
+          <p:nvPr/>
+        </p:nvSpPr>
+        <p:spPr>
+          <a:xfrm>
+            <a:off x="9509760" y="2066544"/>
+            <a:ext cx="2148840" cy="310896"/>
+          </a:xfrm>
+          <a:prstGeom prst="rect">
+            <a:avLst/>
+          </a:prstGeom>
+          <a:noFill/>
+          <a:ln/>
+        </p:spPr>
+        <p:txBody>
+          <a:bodyPr wrap="square" lIns="0" tIns="0" rIns="0" bIns="0" rtlCol="0" anchor="ctr"/>
+          <a:lstStyle/>
+          <a:p>
             <a:pPr indent="0" marL="0">
               <a:buNone/>
             </a:pPr>
@@ -3207,22 +3320,22 @@
                 <a:ea typeface="Calibri" pitchFamily="34" charset="-122"/>
                 <a:cs typeface="Calibri" pitchFamily="34" charset="-120"/>
               </a:rPr>
-              <a:t>saisonnalité, croissance, périodes</a:t>
-            </a:r>
-            <a:endParaRPr lang="en-US" sz="1250" dirty="0"/>
-          </a:p>
-        </p:txBody>
-      </p:sp>
-      <p:sp>
-        <p:nvSpPr>
-          <p:cNvPr id="11" name="Shape 8"/>
+              <a:t>Trafic</a:t>
+            </a:r>
+            <a:endParaRPr lang="en-US" sz="1100" dirty="0"/>
+          </a:p>
+        </p:txBody>
+      </p:sp>
+      <p:sp>
+        <p:nvSpPr>
+          <p:cNvPr id="15" name="Shape 11"/>
           <p:cNvSpPr/>
           <p:nvPr/>
         </p:nvSpPr>
         <p:spPr>
           <a:xfrm>
-            <a:off x="5806440" y="2542032"/>
-            <a:ext cx="274320" cy="274320"/>
+            <a:off x="9144000" y="2450592"/>
+            <a:ext cx="237744" cy="237744"/>
           </a:xfrm>
           <a:prstGeom prst="ellipse">
             <a:avLst/>
@@ -3240,14 +3353,14 @@
       </p:sp>
       <p:sp>
         <p:nvSpPr>
-          <p:cNvPr id="12" name="Text 9"/>
-          <p:cNvSpPr txBox="1"/>
-          <p:nvPr/>
-        </p:nvSpPr>
-        <p:spPr>
-          <a:xfrm>
-            <a:off x="5806440" y="2569464"/>
-            <a:ext cx="274320" cy="237744"/>
+          <p:cNvPr id="16" name="Text 12"/>
+          <p:cNvSpPr txBox="1"/>
+          <p:nvPr/>
+        </p:nvSpPr>
+        <p:spPr>
+          <a:xfrm>
+            <a:off x="9144000" y="2468880"/>
+            <a:ext cx="237744" cy="201168"/>
           </a:xfrm>
           <a:prstGeom prst="rect">
             <a:avLst/>
@@ -3263,7 +3376,7 @@
               <a:buNone/>
             </a:pPr>
             <a:r>
-              <a:rPr lang="en-US" sz="1000" b="1" dirty="0">
+              <a:rPr lang="en-US" sz="900" b="1" dirty="0">
                 <a:solidFill>
                   <a:srgbClr val="FFFFFF"/>
                 </a:solidFill>
@@ -3273,45 +3386,31 @@
               </a:rPr>
               <a:t>3</a:t>
             </a:r>
-            <a:endParaRPr lang="en-US" sz="1000" dirty="0"/>
-          </a:p>
-        </p:txBody>
-      </p:sp>
-      <p:sp>
-        <p:nvSpPr>
-          <p:cNvPr id="13" name="Text 10"/>
-          <p:cNvSpPr txBox="1"/>
-          <p:nvPr/>
-        </p:nvSpPr>
-        <p:spPr>
-          <a:xfrm>
-            <a:off x="6236208" y="2487168"/>
-            <a:ext cx="5394960" cy="384048"/>
-          </a:xfrm>
-          <a:prstGeom prst="rect">
-            <a:avLst/>
-          </a:prstGeom>
-          <a:noFill/>
-          <a:ln/>
-        </p:spPr>
-        <p:txBody>
-          <a:bodyPr wrap="square" lIns="0" tIns="0" rIns="0" bIns="0" rtlCol="0" anchor="ctr"/>
-          <a:lstStyle/>
-          <a:p>
-            <a:pPr indent="0" marL="0">
-              <a:buNone/>
-            </a:pPr>
-            <a:r>
-              <a:rPr lang="en-US" sz="1250" b="1" dirty="0">
-                <a:solidFill>
-                  <a:srgbClr val="12202B"/>
-                </a:solidFill>
-                <a:latin typeface="Calibri" pitchFamily="34" charset="0"/>
-                <a:ea typeface="Calibri" pitchFamily="34" charset="-122"/>
-                <a:cs typeface="Calibri" pitchFamily="34" charset="-120"/>
-              </a:rPr>
-              <a:t>Retards  </a:t>
-            </a:r>
+            <a:endParaRPr lang="en-US" sz="900" dirty="0"/>
+          </a:p>
+        </p:txBody>
+      </p:sp>
+      <p:sp>
+        <p:nvSpPr>
+          <p:cNvPr id="17" name="Text 13"/>
+          <p:cNvSpPr txBox="1"/>
+          <p:nvPr/>
+        </p:nvSpPr>
+        <p:spPr>
+          <a:xfrm>
+            <a:off x="9509760" y="2414016"/>
+            <a:ext cx="2148840" cy="310896"/>
+          </a:xfrm>
+          <a:prstGeom prst="rect">
+            <a:avLst/>
+          </a:prstGeom>
+          <a:noFill/>
+          <a:ln/>
+        </p:spPr>
+        <p:txBody>
+          <a:bodyPr wrap="square" lIns="0" tIns="0" rIns="0" bIns="0" rtlCol="0" anchor="ctr"/>
+          <a:lstStyle/>
+          <a:p>
             <a:pPr indent="0" marL="0">
               <a:buNone/>
             </a:pPr>
@@ -3324,22 +3423,22 @@
                 <a:ea typeface="Calibri" pitchFamily="34" charset="-122"/>
                 <a:cs typeface="Calibri" pitchFamily="34" charset="-120"/>
               </a:rPr>
-              <a:t>compagnies, aéroports, vitesse, extrêmes</a:t>
-            </a:r>
-            <a:endParaRPr lang="en-US" sz="1250" dirty="0"/>
-          </a:p>
-        </p:txBody>
-      </p:sp>
-      <p:sp>
-        <p:nvSpPr>
-          <p:cNvPr id="14" name="Shape 11"/>
+              <a:t>Retards</a:t>
+            </a:r>
+            <a:endParaRPr lang="en-US" sz="1100" dirty="0"/>
+          </a:p>
+        </p:txBody>
+      </p:sp>
+      <p:sp>
+        <p:nvSpPr>
+          <p:cNvPr id="18" name="Shape 14"/>
           <p:cNvSpPr/>
           <p:nvPr/>
         </p:nvSpPr>
         <p:spPr>
           <a:xfrm>
-            <a:off x="5806440" y="3054096"/>
-            <a:ext cx="274320" cy="274320"/>
+            <a:off x="9144000" y="2798064"/>
+            <a:ext cx="237744" cy="237744"/>
           </a:xfrm>
           <a:prstGeom prst="ellipse">
             <a:avLst/>
@@ -3357,14 +3456,14 @@
       </p:sp>
       <p:sp>
         <p:nvSpPr>
-          <p:cNvPr id="15" name="Text 12"/>
-          <p:cNvSpPr txBox="1"/>
-          <p:nvPr/>
-        </p:nvSpPr>
-        <p:spPr>
-          <a:xfrm>
-            <a:off x="5806440" y="3081528"/>
-            <a:ext cx="274320" cy="237744"/>
+          <p:cNvPr id="19" name="Text 15"/>
+          <p:cNvSpPr txBox="1"/>
+          <p:nvPr/>
+        </p:nvSpPr>
+        <p:spPr>
+          <a:xfrm>
+            <a:off x="9144000" y="2816352"/>
+            <a:ext cx="237744" cy="201168"/>
           </a:xfrm>
           <a:prstGeom prst="rect">
             <a:avLst/>
@@ -3380,7 +3479,7 @@
               <a:buNone/>
             </a:pPr>
             <a:r>
-              <a:rPr lang="en-US" sz="1000" b="1" dirty="0">
+              <a:rPr lang="en-US" sz="900" b="1" dirty="0">
                 <a:solidFill>
                   <a:srgbClr val="FFFFFF"/>
                 </a:solidFill>
@@ -3390,45 +3489,31 @@
               </a:rPr>
               <a:t>4</a:t>
             </a:r>
-            <a:endParaRPr lang="en-US" sz="1000" dirty="0"/>
-          </a:p>
-        </p:txBody>
-      </p:sp>
-      <p:sp>
-        <p:nvSpPr>
-          <p:cNvPr id="16" name="Text 13"/>
-          <p:cNvSpPr txBox="1"/>
-          <p:nvPr/>
-        </p:nvSpPr>
-        <p:spPr>
-          <a:xfrm>
-            <a:off x="6236208" y="2999232"/>
-            <a:ext cx="5394960" cy="384048"/>
-          </a:xfrm>
-          <a:prstGeom prst="rect">
-            <a:avLst/>
-          </a:prstGeom>
-          <a:noFill/>
-          <a:ln/>
-        </p:spPr>
-        <p:txBody>
-          <a:bodyPr wrap="square" lIns="0" tIns="0" rIns="0" bIns="0" rtlCol="0" anchor="ctr"/>
-          <a:lstStyle/>
-          <a:p>
-            <a:pPr indent="0" marL="0">
-              <a:buNone/>
-            </a:pPr>
-            <a:r>
-              <a:rPr lang="en-US" sz="1250" b="1" dirty="0">
-                <a:solidFill>
-                  <a:srgbClr val="12202B"/>
-                </a:solidFill>
-                <a:latin typeface="Calibri" pitchFamily="34" charset="0"/>
-                <a:ea typeface="Calibri" pitchFamily="34" charset="-122"/>
-                <a:cs typeface="Calibri" pitchFamily="34" charset="-120"/>
-              </a:rPr>
-              <a:t>Annulations  </a:t>
-            </a:r>
+            <a:endParaRPr lang="en-US" sz="900" dirty="0"/>
+          </a:p>
+        </p:txBody>
+      </p:sp>
+      <p:sp>
+        <p:nvSpPr>
+          <p:cNvPr id="20" name="Text 16"/>
+          <p:cNvSpPr txBox="1"/>
+          <p:nvPr/>
+        </p:nvSpPr>
+        <p:spPr>
+          <a:xfrm>
+            <a:off x="9509760" y="2761488"/>
+            <a:ext cx="2148840" cy="310896"/>
+          </a:xfrm>
+          <a:prstGeom prst="rect">
+            <a:avLst/>
+          </a:prstGeom>
+          <a:noFill/>
+          <a:ln/>
+        </p:spPr>
+        <p:txBody>
+          <a:bodyPr wrap="square" lIns="0" tIns="0" rIns="0" bIns="0" rtlCol="0" anchor="ctr"/>
+          <a:lstStyle/>
+          <a:p>
             <a:pPr indent="0" marL="0">
               <a:buNone/>
             </a:pPr>
@@ -3441,22 +3526,22 @@
                 <a:ea typeface="Calibri" pitchFamily="34" charset="-122"/>
                 <a:cs typeface="Calibri" pitchFamily="34" charset="-120"/>
               </a:rPr>
-              <a:t>volumétrie et qualité des données</a:t>
-            </a:r>
-            <a:endParaRPr lang="en-US" sz="1250" dirty="0"/>
-          </a:p>
-        </p:txBody>
-      </p:sp>
-      <p:sp>
-        <p:nvSpPr>
-          <p:cNvPr id="17" name="Shape 14"/>
+              <a:t>Annulations</a:t>
+            </a:r>
+            <a:endParaRPr lang="en-US" sz="1100" dirty="0"/>
+          </a:p>
+        </p:txBody>
+      </p:sp>
+      <p:sp>
+        <p:nvSpPr>
+          <p:cNvPr id="21" name="Shape 17"/>
           <p:cNvSpPr/>
           <p:nvPr/>
         </p:nvSpPr>
         <p:spPr>
           <a:xfrm>
-            <a:off x="5806440" y="3566160"/>
-            <a:ext cx="274320" cy="274320"/>
+            <a:off x="9144000" y="3145536"/>
+            <a:ext cx="237744" cy="237744"/>
           </a:xfrm>
           <a:prstGeom prst="ellipse">
             <a:avLst/>
@@ -3474,14 +3559,14 @@
       </p:sp>
       <p:sp>
         <p:nvSpPr>
-          <p:cNvPr id="18" name="Text 15"/>
-          <p:cNvSpPr txBox="1"/>
-          <p:nvPr/>
-        </p:nvSpPr>
-        <p:spPr>
-          <a:xfrm>
-            <a:off x="5806440" y="3593592"/>
-            <a:ext cx="274320" cy="237744"/>
+          <p:cNvPr id="22" name="Text 18"/>
+          <p:cNvSpPr txBox="1"/>
+          <p:nvPr/>
+        </p:nvSpPr>
+        <p:spPr>
+          <a:xfrm>
+            <a:off x="9144000" y="3163824"/>
+            <a:ext cx="237744" cy="201168"/>
           </a:xfrm>
           <a:prstGeom prst="rect">
             <a:avLst/>
@@ -3497,7 +3582,7 @@
               <a:buNone/>
             </a:pPr>
             <a:r>
-              <a:rPr lang="en-US" sz="1000" b="1" dirty="0">
+              <a:rPr lang="en-US" sz="900" b="1" dirty="0">
                 <a:solidFill>
                   <a:srgbClr val="FFFFFF"/>
                 </a:solidFill>
@@ -3507,45 +3592,31 @@
               </a:rPr>
               <a:t>5</a:t>
             </a:r>
-            <a:endParaRPr lang="en-US" sz="1000" dirty="0"/>
-          </a:p>
-        </p:txBody>
-      </p:sp>
-      <p:sp>
-        <p:nvSpPr>
-          <p:cNvPr id="19" name="Text 16"/>
-          <p:cNvSpPr txBox="1"/>
-          <p:nvPr/>
-        </p:nvSpPr>
-        <p:spPr>
-          <a:xfrm>
-            <a:off x="6236208" y="3511296"/>
-            <a:ext cx="5394960" cy="384048"/>
-          </a:xfrm>
-          <a:prstGeom prst="rect">
-            <a:avLst/>
-          </a:prstGeom>
-          <a:noFill/>
-          <a:ln/>
-        </p:spPr>
-        <p:txBody>
-          <a:bodyPr wrap="square" lIns="0" tIns="0" rIns="0" bIns="0" rtlCol="0" anchor="ctr"/>
-          <a:lstStyle/>
-          <a:p>
-            <a:pPr indent="0" marL="0">
-              <a:buNone/>
-            </a:pPr>
-            <a:r>
-              <a:rPr lang="en-US" sz="1250" b="1" dirty="0">
-                <a:solidFill>
-                  <a:srgbClr val="12202B"/>
-                </a:solidFill>
-                <a:latin typeface="Calibri" pitchFamily="34" charset="0"/>
-                <a:ea typeface="Calibri" pitchFamily="34" charset="-122"/>
-                <a:cs typeface="Calibri" pitchFamily="34" charset="-120"/>
-              </a:rPr>
-              <a:t>Carte  </a:t>
-            </a:r>
+            <a:endParaRPr lang="en-US" sz="900" dirty="0"/>
+          </a:p>
+        </p:txBody>
+      </p:sp>
+      <p:sp>
+        <p:nvSpPr>
+          <p:cNvPr id="23" name="Text 19"/>
+          <p:cNvSpPr txBox="1"/>
+          <p:nvPr/>
+        </p:nvSpPr>
+        <p:spPr>
+          <a:xfrm>
+            <a:off x="9509760" y="3108960"/>
+            <a:ext cx="2148840" cy="310896"/>
+          </a:xfrm>
+          <a:prstGeom prst="rect">
+            <a:avLst/>
+          </a:prstGeom>
+          <a:noFill/>
+          <a:ln/>
+        </p:spPr>
+        <p:txBody>
+          <a:bodyPr wrap="square" lIns="0" tIns="0" rIns="0" bIns="0" rtlCol="0" anchor="ctr"/>
+          <a:lstStyle/>
+          <a:p>
             <a:pPr indent="0" marL="0">
               <a:buNone/>
             </a:pPr>
@@ -3558,22 +3629,22 @@
                 <a:ea typeface="Calibri" pitchFamily="34" charset="-122"/>
                 <a:cs typeface="Calibri" pitchFamily="34" charset="-120"/>
               </a:rPr>
-              <a:t>réseau origine → destination</a:t>
-            </a:r>
-            <a:endParaRPr lang="en-US" sz="1250" dirty="0"/>
-          </a:p>
-        </p:txBody>
-      </p:sp>
-      <p:sp>
-        <p:nvSpPr>
-          <p:cNvPr id="20" name="Shape 17"/>
+              <a:t>Carte</a:t>
+            </a:r>
+            <a:endParaRPr lang="en-US" sz="1100" dirty="0"/>
+          </a:p>
+        </p:txBody>
+      </p:sp>
+      <p:sp>
+        <p:nvSpPr>
+          <p:cNvPr id="24" name="Shape 20"/>
           <p:cNvSpPr/>
           <p:nvPr/>
         </p:nvSpPr>
         <p:spPr>
           <a:xfrm>
-            <a:off x="5806440" y="4078224"/>
-            <a:ext cx="274320" cy="274320"/>
+            <a:off x="9144000" y="3493008"/>
+            <a:ext cx="237744" cy="237744"/>
           </a:xfrm>
           <a:prstGeom prst="ellipse">
             <a:avLst/>
@@ -3591,14 +3662,14 @@
       </p:sp>
       <p:sp>
         <p:nvSpPr>
-          <p:cNvPr id="21" name="Text 18"/>
-          <p:cNvSpPr txBox="1"/>
-          <p:nvPr/>
-        </p:nvSpPr>
-        <p:spPr>
-          <a:xfrm>
-            <a:off x="5806440" y="4105656"/>
-            <a:ext cx="274320" cy="237744"/>
+          <p:cNvPr id="25" name="Text 21"/>
+          <p:cNvSpPr txBox="1"/>
+          <p:nvPr/>
+        </p:nvSpPr>
+        <p:spPr>
+          <a:xfrm>
+            <a:off x="9144000" y="3511296"/>
+            <a:ext cx="237744" cy="201168"/>
           </a:xfrm>
           <a:prstGeom prst="rect">
             <a:avLst/>
@@ -3614,7 +3685,7 @@
               <a:buNone/>
             </a:pPr>
             <a:r>
-              <a:rPr lang="en-US" sz="1000" b="1" dirty="0">
+              <a:rPr lang="en-US" sz="900" b="1" dirty="0">
                 <a:solidFill>
                   <a:srgbClr val="FFFFFF"/>
                 </a:solidFill>
@@ -3624,45 +3695,31 @@
               </a:rPr>
               <a:t>6</a:t>
             </a:r>
-            <a:endParaRPr lang="en-US" sz="1000" dirty="0"/>
-          </a:p>
-        </p:txBody>
-      </p:sp>
-      <p:sp>
-        <p:nvSpPr>
-          <p:cNvPr id="22" name="Text 19"/>
-          <p:cNvSpPr txBox="1"/>
-          <p:nvPr/>
-        </p:nvSpPr>
-        <p:spPr>
-          <a:xfrm>
-            <a:off x="6236208" y="4023360"/>
-            <a:ext cx="5394960" cy="384048"/>
-          </a:xfrm>
-          <a:prstGeom prst="rect">
-            <a:avLst/>
-          </a:prstGeom>
-          <a:noFill/>
-          <a:ln/>
-        </p:spPr>
-        <p:txBody>
-          <a:bodyPr wrap="square" lIns="0" tIns="0" rIns="0" bIns="0" rtlCol="0" anchor="ctr"/>
-          <a:lstStyle/>
-          <a:p>
-            <a:pPr indent="0" marL="0">
-              <a:buNone/>
-            </a:pPr>
-            <a:r>
-              <a:rPr lang="en-US" sz="1250" b="1" dirty="0">
-                <a:solidFill>
-                  <a:srgbClr val="12202B"/>
-                </a:solidFill>
-                <a:latin typeface="Calibri" pitchFamily="34" charset="0"/>
-                <a:ea typeface="Calibri" pitchFamily="34" charset="-122"/>
-                <a:cs typeface="Calibri" pitchFamily="34" charset="-120"/>
-              </a:rPr>
-              <a:t>Météo  </a:t>
-            </a:r>
+            <a:endParaRPr lang="en-US" sz="900" dirty="0"/>
+          </a:p>
+        </p:txBody>
+      </p:sp>
+      <p:sp>
+        <p:nvSpPr>
+          <p:cNvPr id="26" name="Text 22"/>
+          <p:cNvSpPr txBox="1"/>
+          <p:nvPr/>
+        </p:nvSpPr>
+        <p:spPr>
+          <a:xfrm>
+            <a:off x="9509760" y="3456432"/>
+            <a:ext cx="2148840" cy="310896"/>
+          </a:xfrm>
+          <a:prstGeom prst="rect">
+            <a:avLst/>
+          </a:prstGeom>
+          <a:noFill/>
+          <a:ln/>
+        </p:spPr>
+        <p:txBody>
+          <a:bodyPr wrap="square" lIns="0" tIns="0" rIns="0" bIns="0" rtlCol="0" anchor="ctr"/>
+          <a:lstStyle/>
+          <a:p>
             <a:pPr indent="0" marL="0">
               <a:buNone/>
             </a:pPr>
@@ -3675,22 +3732,22 @@
                 <a:ea typeface="Calibri" pitchFamily="34" charset="-122"/>
                 <a:cs typeface="Calibri" pitchFamily="34" charset="-120"/>
               </a:rPr>
-              <a:t>température, vent, précipitations</a:t>
-            </a:r>
-            <a:endParaRPr lang="en-US" sz="1250" dirty="0"/>
-          </a:p>
-        </p:txBody>
-      </p:sp>
-      <p:sp>
-        <p:nvSpPr>
-          <p:cNvPr id="23" name="Shape 20"/>
+              <a:t>Météo</a:t>
+            </a:r>
+            <a:endParaRPr lang="en-US" sz="1100" dirty="0"/>
+          </a:p>
+        </p:txBody>
+      </p:sp>
+      <p:sp>
+        <p:nvSpPr>
+          <p:cNvPr id="27" name="Shape 23"/>
           <p:cNvSpPr/>
           <p:nvPr/>
         </p:nvSpPr>
         <p:spPr>
           <a:xfrm>
-            <a:off x="5806440" y="4590288"/>
-            <a:ext cx="274320" cy="274320"/>
+            <a:off x="9144000" y="3840480"/>
+            <a:ext cx="237744" cy="237744"/>
           </a:xfrm>
           <a:prstGeom prst="ellipse">
             <a:avLst/>
@@ -3708,14 +3765,14 @@
       </p:sp>
       <p:sp>
         <p:nvSpPr>
-          <p:cNvPr id="24" name="Text 21"/>
-          <p:cNvSpPr txBox="1"/>
-          <p:nvPr/>
-        </p:nvSpPr>
-        <p:spPr>
-          <a:xfrm>
-            <a:off x="5806440" y="4617720"/>
-            <a:ext cx="274320" cy="237744"/>
+          <p:cNvPr id="28" name="Text 24"/>
+          <p:cNvSpPr txBox="1"/>
+          <p:nvPr/>
+        </p:nvSpPr>
+        <p:spPr>
+          <a:xfrm>
+            <a:off x="9144000" y="3858768"/>
+            <a:ext cx="237744" cy="201168"/>
           </a:xfrm>
           <a:prstGeom prst="rect">
             <a:avLst/>
@@ -3731,7 +3788,7 @@
               <a:buNone/>
             </a:pPr>
             <a:r>
-              <a:rPr lang="en-US" sz="1000" b="1" dirty="0">
+              <a:rPr lang="en-US" sz="900" b="1" dirty="0">
                 <a:solidFill>
                   <a:srgbClr val="FFFFFF"/>
                 </a:solidFill>
@@ -3741,36 +3798,36 @@
               </a:rPr>
               <a:t>7</a:t>
             </a:r>
-            <a:endParaRPr lang="en-US" sz="1000" dirty="0"/>
-          </a:p>
-        </p:txBody>
-      </p:sp>
-      <p:sp>
-        <p:nvSpPr>
-          <p:cNvPr id="25" name="Text 22"/>
-          <p:cNvSpPr txBox="1"/>
-          <p:nvPr/>
-        </p:nvSpPr>
-        <p:spPr>
-          <a:xfrm>
-            <a:off x="6236208" y="4535424"/>
-            <a:ext cx="5394960" cy="384048"/>
-          </a:xfrm>
-          <a:prstGeom prst="rect">
-            <a:avLst/>
-          </a:prstGeom>
-          <a:noFill/>
-          <a:ln/>
-        </p:spPr>
-        <p:txBody>
-          <a:bodyPr wrap="square" lIns="0" tIns="0" rIns="0" bIns="0" rtlCol="0" anchor="ctr"/>
-          <a:lstStyle/>
-          <a:p>
-            <a:pPr indent="0" marL="0">
-              <a:buNone/>
-            </a:pPr>
-            <a:r>
-              <a:rPr lang="en-US" sz="1250" b="1" dirty="0">
+            <a:endParaRPr lang="en-US" sz="900" dirty="0"/>
+          </a:p>
+        </p:txBody>
+      </p:sp>
+      <p:sp>
+        <p:nvSpPr>
+          <p:cNvPr id="29" name="Text 25"/>
+          <p:cNvSpPr txBox="1"/>
+          <p:nvPr/>
+        </p:nvSpPr>
+        <p:spPr>
+          <a:xfrm>
+            <a:off x="9509760" y="3803904"/>
+            <a:ext cx="2148840" cy="310896"/>
+          </a:xfrm>
+          <a:prstGeom prst="rect">
+            <a:avLst/>
+          </a:prstGeom>
+          <a:noFill/>
+          <a:ln/>
+        </p:spPr>
+        <p:txBody>
+          <a:bodyPr wrap="square" lIns="0" tIns="0" rIns="0" bIns="0" rtlCol="0" anchor="ctr"/>
+          <a:lstStyle/>
+          <a:p>
+            <a:pPr indent="0" marL="0">
+              <a:buNone/>
+            </a:pPr>
+            <a:r>
+              <a:rPr lang="en-US" sz="1100" b="1" dirty="0">
                 <a:solidFill>
                   <a:srgbClr val="12202B"/>
                 </a:solidFill>
@@ -3778,36 +3835,22 @@
                 <a:ea typeface="Calibri" pitchFamily="34" charset="-122"/>
                 <a:cs typeface="Calibri" pitchFamily="34" charset="-120"/>
               </a:rPr>
-              <a:t>Vols  </a:t>
-            </a:r>
-            <a:pPr indent="0" marL="0">
-              <a:buNone/>
-            </a:pPr>
-            <a:r>
-              <a:rPr lang="en-US" sz="1100" dirty="0">
-                <a:solidFill>
-                  <a:srgbClr val="5A6B7B"/>
-                </a:solidFill>
-                <a:latin typeface="Calibri" pitchFamily="34" charset="0"/>
-                <a:ea typeface="Calibri" pitchFamily="34" charset="-122"/>
-                <a:cs typeface="Calibri" pitchFamily="34" charset="-120"/>
-              </a:rPr>
-              <a:t>explorateur filtré, trié, paginé</a:t>
-            </a:r>
-            <a:endParaRPr lang="en-US" sz="1250" dirty="0"/>
-          </a:p>
-        </p:txBody>
-      </p:sp>
-      <p:sp>
-        <p:nvSpPr>
-          <p:cNvPr id="26" name="Shape 23"/>
+              <a:t>Vols</a:t>
+            </a:r>
+            <a:endParaRPr lang="en-US" sz="1100" dirty="0"/>
+          </a:p>
+        </p:txBody>
+      </p:sp>
+      <p:sp>
+        <p:nvSpPr>
+          <p:cNvPr id="30" name="Shape 26"/>
           <p:cNvSpPr/>
           <p:nvPr/>
         </p:nvSpPr>
         <p:spPr>
           <a:xfrm>
-            <a:off x="5806440" y="5102352"/>
-            <a:ext cx="274320" cy="274320"/>
+            <a:off x="9144000" y="4187952"/>
+            <a:ext cx="237744" cy="237744"/>
           </a:xfrm>
           <a:prstGeom prst="ellipse">
             <a:avLst/>
@@ -3825,14 +3868,14 @@
       </p:sp>
       <p:sp>
         <p:nvSpPr>
-          <p:cNvPr id="27" name="Text 24"/>
-          <p:cNvSpPr txBox="1"/>
-          <p:nvPr/>
-        </p:nvSpPr>
-        <p:spPr>
-          <a:xfrm>
-            <a:off x="5806440" y="5129784"/>
-            <a:ext cx="274320" cy="237744"/>
+          <p:cNvPr id="31" name="Text 27"/>
+          <p:cNvSpPr txBox="1"/>
+          <p:nvPr/>
+        </p:nvSpPr>
+        <p:spPr>
+          <a:xfrm>
+            <a:off x="9144000" y="4206240"/>
+            <a:ext cx="237744" cy="201168"/>
           </a:xfrm>
           <a:prstGeom prst="rect">
             <a:avLst/>
@@ -3848,7 +3891,7 @@
               <a:buNone/>
             </a:pPr>
             <a:r>
-              <a:rPr lang="en-US" sz="1000" b="1" dirty="0">
+              <a:rPr lang="en-US" sz="900" b="1" dirty="0">
                 <a:solidFill>
                   <a:srgbClr val="FFFFFF"/>
                 </a:solidFill>
@@ -3858,36 +3901,36 @@
               </a:rPr>
               <a:t>8</a:t>
             </a:r>
-            <a:endParaRPr lang="en-US" sz="1000" dirty="0"/>
-          </a:p>
-        </p:txBody>
-      </p:sp>
-      <p:sp>
-        <p:nvSpPr>
-          <p:cNvPr id="28" name="Text 25"/>
-          <p:cNvSpPr txBox="1"/>
-          <p:nvPr/>
-        </p:nvSpPr>
-        <p:spPr>
-          <a:xfrm>
-            <a:off x="6236208" y="5047488"/>
-            <a:ext cx="5394960" cy="384048"/>
-          </a:xfrm>
-          <a:prstGeom prst="rect">
-            <a:avLst/>
-          </a:prstGeom>
-          <a:noFill/>
-          <a:ln/>
-        </p:spPr>
-        <p:txBody>
-          <a:bodyPr wrap="square" lIns="0" tIns="0" rIns="0" bIns="0" rtlCol="0" anchor="ctr"/>
-          <a:lstStyle/>
-          <a:p>
-            <a:pPr indent="0" marL="0">
-              <a:buNone/>
-            </a:pPr>
-            <a:r>
-              <a:rPr lang="en-US" sz="1250" b="1" dirty="0">
+            <a:endParaRPr lang="en-US" sz="900" dirty="0"/>
+          </a:p>
+        </p:txBody>
+      </p:sp>
+      <p:sp>
+        <p:nvSpPr>
+          <p:cNvPr id="32" name="Text 28"/>
+          <p:cNvSpPr txBox="1"/>
+          <p:nvPr/>
+        </p:nvSpPr>
+        <p:spPr>
+          <a:xfrm>
+            <a:off x="9509760" y="4151376"/>
+            <a:ext cx="2148840" cy="310896"/>
+          </a:xfrm>
+          <a:prstGeom prst="rect">
+            <a:avLst/>
+          </a:prstGeom>
+          <a:noFill/>
+          <a:ln/>
+        </p:spPr>
+        <p:txBody>
+          <a:bodyPr wrap="square" lIns="0" tIns="0" rIns="0" bIns="0" rtlCol="0" anchor="ctr"/>
+          <a:lstStyle/>
+          <a:p>
+            <a:pPr indent="0" marL="0">
+              <a:buNone/>
+            </a:pPr>
+            <a:r>
+              <a:rPr lang="en-US" sz="1100" b="1" dirty="0">
                 <a:solidFill>
                   <a:srgbClr val="12202B"/>
                 </a:solidFill>
@@ -3895,36 +3938,22 @@
                 <a:ea typeface="Calibri" pitchFamily="34" charset="-122"/>
                 <a:cs typeface="Calibri" pitchFamily="34" charset="-120"/>
               </a:rPr>
-              <a:t>Prévisions  </a:t>
-            </a:r>
-            <a:pPr indent="0" marL="0">
-              <a:buNone/>
-            </a:pPr>
-            <a:r>
-              <a:rPr lang="en-US" sz="1100" dirty="0">
-                <a:solidFill>
-                  <a:srgbClr val="5A6B7B"/>
-                </a:solidFill>
-                <a:latin typeface="Calibri" pitchFamily="34" charset="0"/>
-                <a:ea typeface="Calibri" pitchFamily="34" charset="-122"/>
-                <a:cs typeface="Calibri" pitchFamily="34" charset="-120"/>
-              </a:rPr>
-              <a:t>modèle saisonnier et validation</a:t>
-            </a:r>
-            <a:endParaRPr lang="en-US" sz="1250" dirty="0"/>
-          </a:p>
-        </p:txBody>
-      </p:sp>
-      <p:sp>
-        <p:nvSpPr>
-          <p:cNvPr id="29" name="Shape 26"/>
+              <a:t>Prévisions</a:t>
+            </a:r>
+            <a:endParaRPr lang="en-US" sz="1100" dirty="0"/>
+          </a:p>
+        </p:txBody>
+      </p:sp>
+      <p:sp>
+        <p:nvSpPr>
+          <p:cNvPr id="33" name="Shape 29"/>
           <p:cNvSpPr/>
           <p:nvPr/>
         </p:nvSpPr>
         <p:spPr>
           <a:xfrm>
-            <a:off x="5806440" y="5614416"/>
-            <a:ext cx="274320" cy="274320"/>
+            <a:off x="9144000" y="4535424"/>
+            <a:ext cx="237744" cy="237744"/>
           </a:xfrm>
           <a:prstGeom prst="ellipse">
             <a:avLst/>
@@ -3942,14 +3971,14 @@
       </p:sp>
       <p:sp>
         <p:nvSpPr>
-          <p:cNvPr id="30" name="Text 27"/>
-          <p:cNvSpPr txBox="1"/>
-          <p:nvPr/>
-        </p:nvSpPr>
-        <p:spPr>
-          <a:xfrm>
-            <a:off x="5806440" y="5641848"/>
-            <a:ext cx="274320" cy="237744"/>
+          <p:cNvPr id="34" name="Text 30"/>
+          <p:cNvSpPr txBox="1"/>
+          <p:nvPr/>
+        </p:nvSpPr>
+        <p:spPr>
+          <a:xfrm>
+            <a:off x="9144000" y="4553712"/>
+            <a:ext cx="237744" cy="201168"/>
           </a:xfrm>
           <a:prstGeom prst="rect">
             <a:avLst/>
@@ -3965,7 +3994,7 @@
               <a:buNone/>
             </a:pPr>
             <a:r>
-              <a:rPr lang="en-US" sz="1000" b="1" dirty="0">
+              <a:rPr lang="en-US" sz="900" b="1" dirty="0">
                 <a:solidFill>
                   <a:srgbClr val="FFFFFF"/>
                 </a:solidFill>
@@ -3975,45 +4004,31 @@
               </a:rPr>
               <a:t>9</a:t>
             </a:r>
-            <a:endParaRPr lang="en-US" sz="1000" dirty="0"/>
-          </a:p>
-        </p:txBody>
-      </p:sp>
-      <p:sp>
-        <p:nvSpPr>
-          <p:cNvPr id="31" name="Text 28"/>
-          <p:cNvSpPr txBox="1"/>
-          <p:nvPr/>
-        </p:nvSpPr>
-        <p:spPr>
-          <a:xfrm>
-            <a:off x="6236208" y="5559552"/>
-            <a:ext cx="5394960" cy="384048"/>
-          </a:xfrm>
-          <a:prstGeom prst="rect">
-            <a:avLst/>
-          </a:prstGeom>
-          <a:noFill/>
-          <a:ln/>
-        </p:spPr>
-        <p:txBody>
-          <a:bodyPr wrap="square" lIns="0" tIns="0" rIns="0" bIns="0" rtlCol="0" anchor="ctr"/>
-          <a:lstStyle/>
-          <a:p>
-            <a:pPr indent="0" marL="0">
-              <a:buNone/>
-            </a:pPr>
-            <a:r>
-              <a:rPr lang="en-US" sz="1250" b="1" dirty="0">
-                <a:solidFill>
-                  <a:srgbClr val="12202B"/>
-                </a:solidFill>
-                <a:latin typeface="Calibri" pitchFamily="34" charset="0"/>
-                <a:ea typeface="Calibri" pitchFamily="34" charset="-122"/>
-                <a:cs typeface="Calibri" pitchFamily="34" charset="-120"/>
-              </a:rPr>
-              <a:t>Données &amp; méthode  </a:t>
-            </a:r>
+            <a:endParaRPr lang="en-US" sz="900" dirty="0"/>
+          </a:p>
+        </p:txBody>
+      </p:sp>
+      <p:sp>
+        <p:nvSpPr>
+          <p:cNvPr id="35" name="Text 31"/>
+          <p:cNvSpPr txBox="1"/>
+          <p:nvPr/>
+        </p:nvSpPr>
+        <p:spPr>
+          <a:xfrm>
+            <a:off x="9509760" y="4498848"/>
+            <a:ext cx="2148840" cy="310896"/>
+          </a:xfrm>
+          <a:prstGeom prst="rect">
+            <a:avLst/>
+          </a:prstGeom>
+          <a:noFill/>
+          <a:ln/>
+        </p:spPr>
+        <p:txBody>
+          <a:bodyPr wrap="square" lIns="0" tIns="0" rIns="0" bIns="0" rtlCol="0" anchor="ctr"/>
+          <a:lstStyle/>
+          <a:p>
             <a:pPr indent="0" marL="0">
               <a:buNone/>
             </a:pPr>
@@ -4026,26 +4041,26 @@
                 <a:ea typeface="Calibri" pitchFamily="34" charset="-122"/>
                 <a:cs typeface="Calibri" pitchFamily="34" charset="-120"/>
               </a:rPr>
-              <a:t>sources et conventions de lecture</a:t>
-            </a:r>
-            <a:endParaRPr lang="en-US" sz="1250" dirty="0"/>
-          </a:p>
-        </p:txBody>
-      </p:sp>
-      <p:sp>
-        <p:nvSpPr>
-          <p:cNvPr id="32" name="Shape 29"/>
+              <a:t>Données &amp; méthode</a:t>
+            </a:r>
+            <a:endParaRPr lang="en-US" sz="1100" dirty="0"/>
+          </a:p>
+        </p:txBody>
+      </p:sp>
+      <p:sp>
+        <p:nvSpPr>
+          <p:cNvPr id="36" name="Shape 32"/>
           <p:cNvSpPr/>
           <p:nvPr/>
         </p:nvSpPr>
         <p:spPr>
           <a:xfrm>
-            <a:off x="5806440" y="6053328"/>
-            <a:ext cx="5833872" cy="502920"/>
+            <a:off x="9144000" y="4937760"/>
+            <a:ext cx="2496312" cy="1325880"/>
           </a:xfrm>
           <a:prstGeom prst="roundRect">
             <a:avLst>
-              <a:gd name="adj" fmla="val 14545"/>
+              <a:gd name="adj" fmla="val 5517"/>
             </a:avLst>
           </a:prstGeom>
           <a:solidFill>
@@ -4057,18 +4072,64 @@
             </a:solidFill>
             <a:prstDash val="solid"/>
           </a:ln>
-        </p:spPr>
-      </p:sp>
-      <p:sp>
-        <p:nvSpPr>
-          <p:cNvPr id="33" name="Text 30"/>
-          <p:cNvSpPr txBox="1"/>
-          <p:nvPr/>
-        </p:nvSpPr>
-        <p:spPr>
-          <a:xfrm>
-            <a:off x="5989320" y="6126480"/>
-            <a:ext cx="5486400" cy="384048"/>
+          <a:effectLst>
+            <a:outerShdw sx="100000" sy="100000" kx="0" ky="0" algn="bl" rotWithShape="0" blurRad="101600" dist="508" dir="5400000">
+              <a:srgbClr val="9FB3C4">
+                <a:alpha val="28000"/>
+              </a:srgbClr>
+            </a:outerShdw>
+          </a:effectLst>
+        </p:spPr>
+      </p:sp>
+      <p:sp>
+        <p:nvSpPr>
+          <p:cNvPr id="37" name="Text 33"/>
+          <p:cNvSpPr txBox="1"/>
+          <p:nvPr/>
+        </p:nvSpPr>
+        <p:spPr>
+          <a:xfrm>
+            <a:off x="9326880" y="5047488"/>
+            <a:ext cx="2148840" cy="237744"/>
+          </a:xfrm>
+          <a:prstGeom prst="rect">
+            <a:avLst/>
+          </a:prstGeom>
+          <a:noFill/>
+          <a:ln/>
+        </p:spPr>
+        <p:txBody>
+          <a:bodyPr wrap="square" lIns="0" tIns="0" rIns="0" bIns="0" rtlCol="0" anchor="ctr"/>
+          <a:lstStyle/>
+          <a:p>
+            <a:pPr indent="0" marL="0">
+              <a:buNone/>
+            </a:pPr>
+            <a:r>
+              <a:rPr lang="en-US" sz="1050" b="1" dirty="0">
+                <a:solidFill>
+                  <a:srgbClr val="1D8AC1"/>
+                </a:solidFill>
+                <a:latin typeface="Calibri" pitchFamily="34" charset="0"/>
+                <a:ea typeface="Calibri" pitchFamily="34" charset="-122"/>
+                <a:cs typeface="Calibri" pitchFamily="34" charset="-120"/>
+              </a:rPr>
+              <a:t>Ce qui compte</a:t>
+            </a:r>
+            <a:endParaRPr lang="en-US" sz="1050" dirty="0"/>
+          </a:p>
+        </p:txBody>
+      </p:sp>
+      <p:sp>
+        <p:nvSpPr>
+          <p:cNvPr id="38" name="Text 34"/>
+          <p:cNvSpPr txBox="1"/>
+          <p:nvPr/>
+        </p:nvSpPr>
+        <p:spPr>
+          <a:xfrm>
+            <a:off x="9326880" y="5303520"/>
+            <a:ext cx="2148840" cy="868680"/>
           </a:xfrm>
           <a:prstGeom prst="rect">
             <a:avLst/>
@@ -4082,12 +4143,12 @@
           <a:p>
             <a:pPr indent="0" marL="0">
               <a:lnSpc>
-                <a:spcPts val="1300"/>
+                <a:spcPts val="1200"/>
               </a:lnSpc>
               <a:buNone/>
             </a:pPr>
             <a:r>
-              <a:rPr lang="en-US" sz="1050" dirty="0">
+              <a:rPr lang="en-US" sz="900" dirty="0">
                 <a:solidFill>
                   <a:srgbClr val="5A6B7B"/>
                 </a:solidFill>
@@ -4095,9 +4156,9 @@
                 <a:ea typeface="Calibri" pitchFamily="34" charset="-122"/>
                 <a:cs typeface="Calibri" pitchFamily="34" charset="-120"/>
               </a:rPr>
-              <a:t>Aucune connexion à MySQL : tout passe par l'API. Si elle tombe, le badge passe au rouge et chaque graphique affiche l'erreur — la session ne tombe jamais.</a:t>
-            </a:r>
-            <a:endParaRPr lang="en-US" sz="1050" dirty="0"/>
+              <a:t>Aucune connexion à MySQL : tout passe par l'API. Filtres, tri et pagination sont exécutés côté serveur, le dashboard ne charge qu'une page à la fois. Démonstration live sur les onglets Vols et Carte.</a:t>
+            </a:r>
+            <a:endParaRPr lang="en-US" sz="900" dirty="0"/>
           </a:p>
         </p:txBody>
       </p:sp>

</xml_diff>